<commit_message>
Fix slide 5 gate visual and slide 8 principle/Express contradiction
- Slide 5: mark the /speckit-plan box with a solid fill instead of
  claiming a branch annotation the diagram helper never rendered.
- Slide 8 (2/2): swap the Principle V/Express example, which
  contradicted itself (principle literally names Express), for
  Principle I paired with the plan.md Constitution Check line.

Co-Authored-By: Claude Sonnet 5 <noreply@anthropic.com>
</commit_message>
<xml_diff>
--- a/presentation/SpecDrivenDevelopment.pptx
+++ b/presentation/SpecDrivenDevelopment.pptx
@@ -9625,9 +9625,9 @@
             </a:avLst>
           </a:prstGeom>
           <a:solidFill>
-            <a:srgbClr val="DDE8F5"/>
+            <a:srgbClr val="1D6FBC"/>
           </a:solidFill>
-          <a:ln w="19050">
+          <a:ln w="31750">
             <a:solidFill>
               <a:srgbClr val="1D6FBC"/>
             </a:solidFill>
@@ -9660,9 +9660,9 @@
               <a:buNone/>
             </a:pPr>
             <a:r>
-              <a:rPr lang="en-US" sz="1100" dirty="0">
-                <a:solidFill>
-                  <a:srgbClr val="0C1B35"/>
+              <a:rPr lang="en-US" sz="1100" b="1" dirty="0">
+                <a:solidFill>
+                  <a:srgbClr val="FFFFFF"/>
                 </a:solidFill>
                 <a:latin typeface="Calibri" pitchFamily="34" charset="0"/>
                 <a:ea typeface="Calibri" pitchFamily="34" charset="-122"/>
@@ -9677,9 +9677,9 @@
               <a:buNone/>
             </a:pPr>
             <a:r>
-              <a:rPr lang="en-US" sz="1100" dirty="0">
-                <a:solidFill>
-                  <a:srgbClr val="0C1B35"/>
+              <a:rPr lang="en-US" sz="1100" b="1" dirty="0">
+                <a:solidFill>
+                  <a:srgbClr val="FFFFFF"/>
                 </a:solidFill>
                 <a:latin typeface="Calibri" pitchFamily="34" charset="0"/>
                 <a:ea typeface="Calibri" pitchFamily="34" charset="-122"/>
@@ -10049,7 +10049,7 @@
                 <a:ea typeface="Calibri" pitchFamily="34" charset="-122"/>
                 <a:cs typeface="Calibri" pitchFamily="34" charset="-120"/>
               </a:rPr>
-              <a:t>Only /speckit-plan has a hard gate — the Constitution Check branch shown above; everything else just flows forward, file to file</a:t>
+              <a:t>Only /speckit-plan has a hard gate — the filled-in box above; everything else just flows forward, file to file</a:t>
             </a:r>
             <a:endParaRPr lang="en-US" sz="1600" dirty="0"/>
           </a:p>
@@ -11445,7 +11445,7 @@
                 <a:ea typeface="Calibri" pitchFamily="34" charset="-122"/>
                 <a:cs typeface="Calibri" pitchFamily="34" charset="-120"/>
               </a:rPr>
-              <a:t>Real contrast from this exact demo — constitution, Principle V: "Minimal Dependencies — use vanilla JavaScript with Express only." ← the PRINCIPLE</a:t>
+              <a:t>Real contrast from this exact demo — constitution, Principle I: "MUST be readable in a single pass by someone who has never seen spec-kit before... prefer fewer files, fewer moving parts." ← the PRINCIPLE</a:t>
             </a:r>
             <a:endParaRPr lang="en-US" sz="2300" dirty="0"/>
           </a:p>
@@ -11485,7 +11485,7 @@
                 <a:ea typeface="Calibri" pitchFamily="34" charset="-122"/>
                 <a:cs typeface="Calibri" pitchFamily="34" charset="-120"/>
               </a:rPr>
-              <a:t>plan.md, Technical Context: "Primary Dependencies: Express 4.x... per constitution Principle V" ← the IMPLEMENTATION CHOICE that satisfies it</a:t>
+              <a:t>plan.md, Constitution Check: "I. Simplicity &amp; Legibility: PASS — four small files total, plain Express routing, no framework magic." ← the IMPLEMENTATION CHOICE that satisfies it</a:t>
             </a:r>
             <a:endParaRPr lang="en-US" sz="2300" dirty="0"/>
           </a:p>
@@ -11525,7 +11525,7 @@
                 <a:ea typeface="Calibri" pitchFamily="34" charset="-122"/>
                 <a:cs typeface="Calibri" pitchFamily="34" charset="-120"/>
               </a:rPr>
-              <a:t>Notice the principle never says "Express" — it only rules out everything except "minimal." The plan is where "minimal" becomes one specific, named choice</a:t>
+              <a:t>Notice the principle never says "four files" or "Express" — it only says fewer and plainer. The plan is where that becomes one specific file count and one named framework</a:t>
             </a:r>
             <a:endParaRPr lang="en-US" sz="2300" dirty="0"/>
           </a:p>

</xml_diff>

<commit_message>
Remove outside-repo path reference from speckit-implement slide
The /speckit-implement slide pointed to ~/speckit-demo/spec-driven/,
a repo not part of this workshop repo and not something attendees
have access to. Dropped the line from the slide bullets and its
matching transcript sentence.

Co-Authored-By: Claude Sonnet 5 <noreply@anthropic.com>
</commit_message>
<xml_diff>
--- a/presentation/SpecDrivenDevelopment.pptx
+++ b/presentation/SpecDrivenDevelopment.pptx
@@ -3923,7 +3923,7 @@
         <p:spPr>
           <a:xfrm>
             <a:off x="457200" y="1572768"/>
-            <a:ext cx="9166225" cy="764692"/>
+            <a:ext cx="9166225" cy="955866"/>
           </a:xfrm>
           <a:prstGeom prst="rect">
             <a:avLst/>
@@ -3962,8 +3962,8 @@
         </p:nvSpPr>
         <p:spPr>
           <a:xfrm>
-            <a:off x="457200" y="2337460"/>
-            <a:ext cx="9166225" cy="764692"/>
+            <a:off x="457200" y="2528634"/>
+            <a:ext cx="9166225" cy="955866"/>
           </a:xfrm>
           <a:prstGeom prst="rect">
             <a:avLst/>
@@ -4002,8 +4002,8 @@
         </p:nvSpPr>
         <p:spPr>
           <a:xfrm>
-            <a:off x="457200" y="3102153"/>
-            <a:ext cx="9166225" cy="764692"/>
+            <a:off x="457200" y="3484499"/>
+            <a:ext cx="9166225" cy="955866"/>
           </a:xfrm>
           <a:prstGeom prst="rect">
             <a:avLst/>
@@ -4042,8 +4042,8 @@
         </p:nvSpPr>
         <p:spPr>
           <a:xfrm>
-            <a:off x="457200" y="3866845"/>
-            <a:ext cx="9166225" cy="764692"/>
+            <a:off x="457200" y="4440365"/>
+            <a:ext cx="9166225" cy="955866"/>
           </a:xfrm>
           <a:prstGeom prst="rect">
             <a:avLst/>
@@ -4069,46 +4069,6 @@
                 <a:cs typeface="Calibri" pitchFamily="34" charset="-120"/>
               </a:rPr>
               <a:t>Why: there's almost nothing left to improvise at this point — every earlier command already decided what to build and why</a:t>
-            </a:r>
-            <a:endParaRPr lang="en-US" sz="2200" dirty="0"/>
-          </a:p>
-        </p:txBody>
-      </p:sp>
-      <p:sp>
-        <p:nvSpPr>
-          <p:cNvPr id="10" name="Text 8"/>
-          <p:cNvSpPr/>
-          <p:nvPr/>
-        </p:nvSpPr>
-        <p:spPr>
-          <a:xfrm>
-            <a:off x="457200" y="4631538"/>
-            <a:ext cx="9166225" cy="764692"/>
-          </a:xfrm>
-          <a:prstGeom prst="rect">
-            <a:avLst/>
-          </a:prstGeom>
-          <a:noFill/>
-          <a:ln/>
-        </p:spPr>
-        <p:txBody>
-          <a:bodyPr wrap="square" rtlCol="0" anchor="ctr"/>
-          <a:lstStyle/>
-          <a:p>
-            <a:pPr marL="254000" indent="-254000">
-              <a:buSzPct val="100000"/>
-              <a:buChar char="•"/>
-            </a:pPr>
-            <a:r>
-              <a:rPr lang="en-US" sz="2200" dirty="0">
-                <a:solidFill>
-                  <a:srgbClr val="0C1B35"/>
-                </a:solidFill>
-                <a:latin typeface="Calibri" pitchFamily="34" charset="0"/>
-                <a:ea typeface="Calibri" pitchFamily="34" charset="-122"/>
-                <a:cs typeface="Calibri" pitchFamily="34" charset="-120"/>
-              </a:rPr>
-              <a:t>The real generated code from this exact run lives in ~/speckit-demo/spec-driven/, if you want to look afterward</a:t>
             </a:r>
             <a:endParaRPr lang="en-US" sz="2200" dirty="0"/>
           </a:p>

</xml_diff>

<commit_message>
Fix overclaim on slide 14: grep doesn't catch a broken FR-### promise
The closing-the-loop slide claimed "grep -rn catches the broken
promise" if a check is deleted but its // FR-001 comment survives.
That's wrong — grep matches the literal string in the comment
regardless of whether the code beneath it still does anything.
Reworded to describe what the ID mechanism actually provides: a
locator that points a reviewer at the right line, not an automated
verifier. Nothing in speckit or this demo runs that grep in CI.

Co-Authored-By: Claude Sonnet 5 <noreply@anthropic.com>
</commit_message>
<xml_diff>
--- a/presentation/SpecDrivenDevelopment.pptx
+++ b/presentation/SpecDrivenDevelopment.pptx
@@ -4934,7 +4934,7 @@
                 <a:ea typeface="Calibri" pitchFamily="34" charset="-122"/>
                 <a:cs typeface="Calibri" pitchFamily="34" charset="-120"/>
               </a:rPr>
-              <a:t>An FR-### ID isn't documentation — it's a promise. grep -rn "FR-" src/ either finds it in the code, or it doesn't. No third answer.</a:t>
+              <a:t>An FR-### ID isn't documentation — it's a locator. grep -rn "FR-" src/ points you at the exact line responsible for a requirement, instead of leaving you to search chat scrollback.</a:t>
             </a:r>
             <a:endParaRPr lang="en-US" sz="1600" dirty="0"/>
           </a:p>
@@ -4951,7 +4951,7 @@
                 <a:ea typeface="Calibri" pitchFamily="34" charset="-122"/>
                 <a:cs typeface="Calibri" pitchFamily="34" charset="-120"/>
               </a:rPr>
-              <a:t>Concretely: FR-001 promised a non-empty description is required — the check sits right under the // FR-001 comment in routes/tasks.js. Delete the check but keep the comment, and the grep catches the broken promise.</a:t>
+              <a:t>Concretely: FR-001 promised a non-empty description is required — the check sits right under the // FR-001 comment in routes/tasks.js. Delete the check but keep the comment, and grep still finds "FR-001" — it can't tell the promise is broken. What changed is that anyone following the ID now lands directly on the missing check, instead of having nowhere to even look. Nothing automated verifies it; the ID just makes verification a one-line lookup instead of a guess.</a:t>
             </a:r>
             <a:endParaRPr lang="en-US" sz="1600" dirty="0"/>
           </a:p>

</xml_diff>

<commit_message>
Drop grep demo from slide 14 — this deck has no live terminal
transcript.md states outright there's no running app behind this
talk (narrated slides only), so telling viewers to "run grep" asked
them to do something the format never delivers on. Slide 14 now
points back at slide 13's already-visible FR-001 excerpt (spec.md,
tasks.md, code comment, all shown as text) as the actual proof,
instead of describing a terminal action nobody will see.

FACILITATION.md is unaffected — that's a separate live-terminal
workshop guide where the grep really does get typed on screen.

Co-Authored-By: Claude Sonnet 5 <noreply@anthropic.com>
</commit_message>
<xml_diff>
--- a/presentation/SpecDrivenDevelopment.pptx
+++ b/presentation/SpecDrivenDevelopment.pptx
@@ -4934,7 +4934,7 @@
                 <a:ea typeface="Calibri" pitchFamily="34" charset="-122"/>
                 <a:cs typeface="Calibri" pitchFamily="34" charset="-120"/>
               </a:rPr>
-              <a:t>An FR-### ID isn't documentation — it's a locator. grep -rn "FR-" src/ points you at the exact line responsible for a requirement, instead of leaving you to search chat scrollback.</a:t>
+              <a:t>SDD's answer: an FR-### ID exists in three places at once — spec.md, tasks.md, and a comment in the code (previous slide) — so the link from decision to code is something you read directly, not something you take on faith.</a:t>
             </a:r>
             <a:endParaRPr lang="en-US" sz="1600" dirty="0"/>
           </a:p>
@@ -4951,7 +4951,7 @@
                 <a:ea typeface="Calibri" pitchFamily="34" charset="-122"/>
                 <a:cs typeface="Calibri" pitchFamily="34" charset="-120"/>
               </a:rPr>
-              <a:t>Concretely: FR-001 promised a non-empty description is required — the check sits right under the // FR-001 comment in routes/tasks.js. Delete the check but keep the comment, and grep still finds "FR-001" — it can't tell the promise is broken. What changed is that anyone following the ID now lands directly on the missing check, instead of having nowhere to even look. Nothing automated verifies it; the ID just makes verification a one-line lookup instead of a guess.</a:t>
+              <a:t>Concretely: FR-001 promised a non-empty description is required, and the check enforcing that sits right under the // FR-001 comment in routes/tasks.js, exactly as shown one slide back. The proof is the code itself — nothing to run, nothing to trust secondhand.</a:t>
             </a:r>
             <a:endParaRPr lang="en-US" sz="1600" dirty="0"/>
           </a:p>

</xml_diff>

<commit_message>
Cut the "Closing the Loop" slide — it duplicated the Traceability Spine
Once the grep-based demo was removed from this slide (previous
commit), all it had left was a near-verbatim restatement of the
Traceability Spine slide's FR-001 example under a "remember the
opening problem" wrapper. Folded its one distinct value — tying the
mechanism back to the talk's opening complaint — into a closing
bullet on the Traceability Spine slide instead, and cut the
now-redundant slide entirely. Deck goes from 18 slides to 17.

Co-Authored-By: Claude Sonnet 5 <noreply@anthropic.com>
</commit_message>
<xml_diff>
--- a/presentation/SpecDrivenDevelopment.pptx
+++ b/presentation/SpecDrivenDevelopment.pptx
@@ -22,10 +22,9 @@
     <p:sldId id="270" r:id="rId16"/>
     <p:sldId id="271" r:id="rId17"/>
     <p:sldId id="272" r:id="rId18"/>
-    <p:sldId id="273" r:id="rId19"/>
   </p:sldIdLst>
   <p:notesMasterIdLst>
-    <p:notesMasterId r:id="rId20"/>
+    <p:notesMasterId r:id="rId19"/>
   </p:notesMasterIdLst>
   <p:sldSz cx="10080625" cy="5670550"/>
   <p:notesSz cx="5670550" cy="10080625"/>
@@ -959,7 +958,7 @@
           <a:p>
             <a:r>
               <a:rPr lang="en-US" dirty="0"/>
-              <a:t>This is the payoff concept — the thing that turns "we wrote some docs" into "we can prove the code matches the docs." Walk this as one concrete story, not four abstract bullets: FR-001 is real content from speckit-demo's actual generated Task List API, not a hypothetical.</a:t>
+              <a:t>This is the payoff concept — the thing that turns "we wrote some docs" into "we can prove the code matches the docs." Walk this as one concrete story, not four abstract bullets: FR-001 is real content from speckit-demo's actual generated Task List API, not a hypothetical. Land the last bullet as the callback to the opening problem from slide 2 — say the opening complaint out loud again before revealing this as its answer.</a:t>
             </a:r>
             <a:endParaRPr lang="en-US" dirty="0"/>
           </a:p>
@@ -1047,7 +1046,7 @@
           <a:p>
             <a:r>
               <a:rPr lang="en-US" dirty="0"/>
-              <a:t>This slide only lands if the audience remembers the opening problem — say it out loud again before revealing the punchline. This is the moment the whole talk has been building to: the opening complaint about vibe-coding gets an actual mechanical answer, not just a process that feels more organized.</a:t>
+              <a:t>Vibe-coding — prompt an AI once and hope — isn't a strawman, it's the default most people are already doing. This table is the honest trade-off, not a case for SDD always winning.</a:t>
             </a:r>
             <a:endParaRPr lang="en-US" dirty="0"/>
           </a:p>
@@ -1135,7 +1134,7 @@
           <a:p>
             <a:r>
               <a:rPr lang="en-US" dirty="0"/>
-              <a:t>Vibe-coding — prompt an AI once and hope — isn't a strawman, it's the default most people are already doing. This table is the honest trade-off, not a case for SDD always winning.</a:t>
+              <a:t>None of these five are needed for a single solo pass like the one this talk has walked through — they're optional rigor that earns its keep once a team, a deadline, or an ambiguous spec is in the picture.</a:t>
             </a:r>
             <a:endParaRPr lang="en-US" dirty="0"/>
           </a:p>
@@ -1223,7 +1222,7 @@
           <a:p>
             <a:r>
               <a:rPr lang="en-US" dirty="0"/>
-              <a:t>None of these five are needed for a single solo pass like the one this talk has walked through — they're optional rigor that earns its keep once a team, a deadline, or an ambiguous spec is in the picture.</a:t>
+              <a:t>Send the audience somewhere concrete instead of ending on a slogan.</a:t>
             </a:r>
             <a:endParaRPr lang="en-US" dirty="0"/>
           </a:p>
@@ -1247,94 +1246,6 @@
             <a:fld id="{F7021451-1387-4CA6-816F-3879F97B5CBC}" type="slidenum">
               <a:rPr lang="en-US"/>
               <a:t>17</a:t>
-            </a:fld>
-            <a:endParaRPr lang="en-US"/>
-          </a:p>
-        </p:txBody>
-      </p:sp>
-    </p:spTree>
-    <p:extLst>
-      <p:ext uri="{BB962C8B-B14F-4D97-AF65-F5344CB8AC3E}">
-        <p14:creationId xmlns:p14="http://schemas.microsoft.com/office/powerpoint/2010/main" val="1024086991"/>
-      </p:ext>
-    </p:extLst>
-  </p:cSld>
-  <p:clrMapOvr>
-    <a:masterClrMapping/>
-  </p:clrMapOvr>
-</p:notes>
-</file>
-
-<file path=ppt/notesSlides/notesSlide18.xml><?xml version="1.0" encoding="utf-8"?>
-<p:notes xmlns:a="http://schemas.openxmlformats.org/drawingml/2006/main" xmlns:r="http://schemas.openxmlformats.org/officeDocument/2006/relationships" xmlns:p="http://schemas.openxmlformats.org/presentationml/2006/main">
-  <p:cSld>
-    <p:spTree>
-      <p:nvGrpSpPr>
-        <p:cNvPr id="1" name=""/>
-        <p:cNvGrpSpPr/>
-        <p:nvPr/>
-      </p:nvGrpSpPr>
-      <p:grpSpPr>
-        <a:xfrm>
-          <a:off x="0" y="0"/>
-          <a:ext cx="0" cy="0"/>
-          <a:chOff x="0" y="0"/>
-          <a:chExt cx="0" cy="0"/>
-        </a:xfrm>
-      </p:grpSpPr>
-      <p:sp>
-        <p:nvSpPr>
-          <p:cNvPr id="2" name="Slide Image Placeholder 1"/>
-          <p:cNvSpPr>
-            <a:spLocks noGrp="1" noRot="1" noChangeAspect="1"/>
-          </p:cNvSpPr>
-          <p:nvPr>
-            <p:ph type="sldImg"/>
-          </p:nvPr>
-        </p:nvSpPr>
-        <p:spPr/>
-      </p:sp>
-      <p:sp>
-        <p:nvSpPr>
-          <p:cNvPr id="3" name="Notes Placeholder 2"/>
-          <p:cNvSpPr>
-            <a:spLocks noGrp="1"/>
-          </p:cNvSpPr>
-          <p:nvPr>
-            <p:ph type="body" idx="1"/>
-          </p:nvPr>
-        </p:nvSpPr>
-        <p:spPr/>
-        <p:txBody>
-          <a:bodyPr/>
-          <a:lstStyle/>
-          <a:p>
-            <a:r>
-              <a:rPr lang="en-US" dirty="0"/>
-              <a:t>Send the audience somewhere concrete instead of ending on a slogan.</a:t>
-            </a:r>
-            <a:endParaRPr lang="en-US" dirty="0"/>
-          </a:p>
-        </p:txBody>
-      </p:sp>
-      <p:sp>
-        <p:nvSpPr>
-          <p:cNvPr id="4" name="Slide Number Placeholder 3"/>
-          <p:cNvSpPr>
-            <a:spLocks noGrp="1"/>
-          </p:cNvSpPr>
-          <p:nvPr>
-            <p:ph type="sldNum" sz="quarter" idx="10"/>
-          </p:nvPr>
-        </p:nvSpPr>
-        <p:spPr/>
-        <p:txBody>
-          <a:bodyPr/>
-          <a:lstStyle/>
-          <a:p>
-            <a:fld id="{F7021451-1387-4CA6-816F-3879F97B5CBC}" type="slidenum">
-              <a:rPr lang="en-US"/>
-              <a:t>18</a:t>
             </a:fld>
             <a:endParaRPr lang="en-US"/>
           </a:p>
@@ -4668,7 +4579,7 @@
                 <a:ea typeface="Calibri" pitchFamily="34" charset="-122"/>
                 <a:cs typeface="Calibri" pitchFamily="34" charset="-120"/>
               </a:rPr>
-              <a:t>Follow the ID and you can point at the exact line of running code a one-sentence requirement became</a:t>
+              <a:t>This is the direct answer to the opening problem: nobody could check why the code was built this way before — now the link from decision to code is something you read, not something you take on faith</a:t>
             </a:r>
             <a:endParaRPr lang="en-US" sz="1700" dirty="0"/>
           </a:p>
@@ -4803,7 +4714,7 @@
                 <a:ea typeface="Calibri" pitchFamily="34" charset="-122"/>
                 <a:cs typeface="Calibri" pitchFamily="34" charset="-120"/>
               </a:rPr>
-              <a:t>Why This Matters: Closing the Loop</a:t>
+              <a:t>Spec-Driven Development vs. Vibe-Coding</a:t>
             </a:r>
             <a:endParaRPr lang="en-US" sz="3000" dirty="0"/>
           </a:p>
@@ -4834,292 +4745,9 @@
           </a:ln>
         </p:spPr>
       </p:sp>
-      <p:sp>
-        <p:nvSpPr>
-          <p:cNvPr id="6" name="Shape 4"/>
-          <p:cNvSpPr/>
-          <p:nvPr/>
-        </p:nvSpPr>
-        <p:spPr>
-          <a:xfrm>
-            <a:off x="457200" y="1847088"/>
-            <a:ext cx="9166225" cy="3274822"/>
-          </a:xfrm>
-          <a:prstGeom prst="rect">
-            <a:avLst/>
-          </a:prstGeom>
-          <a:solidFill>
-            <a:srgbClr val="DDE8F5"/>
-          </a:solidFill>
-          <a:ln w="25400">
-            <a:solidFill>
-              <a:srgbClr val="1D6FBC"/>
-            </a:solidFill>
-            <a:prstDash val="solid"/>
-          </a:ln>
-        </p:spPr>
-      </p:sp>
-      <p:sp>
-        <p:nvSpPr>
-          <p:cNvPr id="7" name="Shape 5"/>
-          <p:cNvSpPr/>
-          <p:nvPr/>
-        </p:nvSpPr>
-        <p:spPr>
-          <a:xfrm>
-            <a:off x="457200" y="1847088"/>
-            <a:ext cx="73152" cy="3274822"/>
-          </a:xfrm>
-          <a:prstGeom prst="rect">
-            <a:avLst/>
-          </a:prstGeom>
-          <a:solidFill>
-            <a:srgbClr val="1D6FBC"/>
-          </a:solidFill>
-          <a:ln w="12700">
-            <a:solidFill>
-              <a:srgbClr val="1D6FBC"/>
-            </a:solidFill>
-            <a:prstDash val="solid"/>
-          </a:ln>
-        </p:spPr>
-      </p:sp>
-      <p:sp>
-        <p:nvSpPr>
-          <p:cNvPr id="8" name="Text 6"/>
-          <p:cNvSpPr/>
-          <p:nvPr/>
-        </p:nvSpPr>
-        <p:spPr>
-          <a:xfrm>
-            <a:off x="685800" y="1984248"/>
-            <a:ext cx="8846185" cy="3000502"/>
-          </a:xfrm>
-          <a:prstGeom prst="rect">
-            <a:avLst/>
-          </a:prstGeom>
-          <a:noFill/>
-          <a:ln/>
-        </p:spPr>
-        <p:txBody>
-          <a:bodyPr wrap="square" rtlCol="0" anchor="ctr"/>
-          <a:lstStyle/>
-          <a:p>
-            <a:pPr indent="0" marL="0">
-              <a:buNone/>
-            </a:pPr>
-            <a:r>
-              <a:rPr lang="en-US" sz="1600" b="1" dirty="0">
-                <a:solidFill>
-                  <a:srgbClr val="0C1B35"/>
-                </a:solidFill>
-                <a:latin typeface="Calibri" pitchFamily="34" charset="0"/>
-                <a:ea typeface="Calibri" pitchFamily="34" charset="-122"/>
-                <a:cs typeface="Calibri" pitchFamily="34" charset="-120"/>
-              </a:rPr>
-              <a:t>The opening problem: nobody could check why the code was built this way — nothing was written down to check it against.</a:t>
-            </a:r>
-            <a:endParaRPr lang="en-US" sz="1600" dirty="0"/>
-          </a:p>
-          <a:p>
-            <a:pPr indent="0" marL="0">
-              <a:buNone/>
-            </a:pPr>
-            <a:r>
-              <a:rPr lang="en-US" sz="1600" dirty="0">
-                <a:solidFill>
-                  <a:srgbClr val="0C1B35"/>
-                </a:solidFill>
-                <a:latin typeface="Calibri" pitchFamily="34" charset="0"/>
-                <a:ea typeface="Calibri" pitchFamily="34" charset="-122"/>
-                <a:cs typeface="Calibri" pitchFamily="34" charset="-120"/>
-              </a:rPr>
-              <a:t>SDD's answer: an FR-### ID exists in three places at once — spec.md, tasks.md, and a comment in the code (previous slide) — so the link from decision to code is something you read directly, not something you take on faith.</a:t>
-            </a:r>
-            <a:endParaRPr lang="en-US" sz="1600" dirty="0"/>
-          </a:p>
-          <a:p>
-            <a:pPr indent="0" marL="0">
-              <a:buNone/>
-            </a:pPr>
-            <a:r>
-              <a:rPr lang="en-US" sz="1600" dirty="0">
-                <a:solidFill>
-                  <a:srgbClr val="0C1B35"/>
-                </a:solidFill>
-                <a:latin typeface="Calibri" pitchFamily="34" charset="0"/>
-                <a:ea typeface="Calibri" pitchFamily="34" charset="-122"/>
-                <a:cs typeface="Calibri" pitchFamily="34" charset="-120"/>
-              </a:rPr>
-              <a:t>Concretely: FR-001 promised a non-empty description is required, and the check enforcing that sits right under the // FR-001 comment in routes/tasks.js, exactly as shown one slide back. The proof is the code itself — nothing to run, nothing to trust secondhand.</a:t>
-            </a:r>
-            <a:endParaRPr lang="en-US" sz="1600" dirty="0"/>
-          </a:p>
-        </p:txBody>
-      </p:sp>
-    </p:spTree>
-  </p:cSld>
-  <p:clrMapOvr>
-    <a:masterClrMapping/>
-  </p:clrMapOvr>
-</p:sld>
-</file>
-
-<file path=ppt/slides/slide16.xml><?xml version="1.0" encoding="utf-8"?>
-<p:sld xmlns:a="http://schemas.openxmlformats.org/drawingml/2006/main" xmlns:r="http://schemas.openxmlformats.org/officeDocument/2006/relationships" xmlns:p="http://schemas.openxmlformats.org/presentationml/2006/main">
-  <p:cSld name="Slide 16">
-    <p:bg>
-      <p:bgPr>
-        <a:solidFill>
-          <a:srgbClr val="F0F6FF"/>
-        </a:solidFill>
-      </p:bgPr>
-    </p:bg>
-    <p:spTree>
-      <p:nvGrpSpPr>
-        <p:cNvPr id="1" name=""/>
-        <p:cNvGrpSpPr/>
-        <p:nvPr/>
-      </p:nvGrpSpPr>
-      <p:grpSpPr>
-        <a:xfrm>
-          <a:off x="0" y="0"/>
-          <a:ext cx="0" cy="0"/>
-          <a:chOff x="0" y="0"/>
-          <a:chExt cx="0" cy="0"/>
-        </a:xfrm>
-      </p:grpSpPr>
-      <p:sp>
-        <p:nvSpPr>
-          <p:cNvPr id="2" name="Shape 0"/>
-          <p:cNvSpPr/>
-          <p:nvPr/>
-        </p:nvSpPr>
-        <p:spPr>
-          <a:xfrm>
-            <a:off x="457200" y="201168"/>
-            <a:ext cx="1828800" cy="347472"/>
-          </a:xfrm>
-          <a:prstGeom prst="rect">
-            <a:avLst/>
-          </a:prstGeom>
-          <a:solidFill>
-            <a:srgbClr val="1D6FBC"/>
-          </a:solidFill>
-          <a:ln w="9525">
-            <a:solidFill>
-              <a:srgbClr val="1D6FBC"/>
-            </a:solidFill>
-            <a:prstDash val="solid"/>
-          </a:ln>
-        </p:spPr>
-      </p:sp>
-      <p:sp>
-        <p:nvSpPr>
-          <p:cNvPr id="3" name="Text 1"/>
-          <p:cNvSpPr/>
-          <p:nvPr/>
-        </p:nvSpPr>
-        <p:spPr>
-          <a:xfrm>
-            <a:off x="457200" y="201168"/>
-            <a:ext cx="1828800" cy="347472"/>
-          </a:xfrm>
-          <a:prstGeom prst="rect">
-            <a:avLst/>
-          </a:prstGeom>
-          <a:noFill/>
-          <a:ln/>
-        </p:spPr>
-        <p:txBody>
-          <a:bodyPr wrap="square" rtlCol="0" anchor="ctr"/>
-          <a:lstStyle/>
-          <a:p>
-            <a:pPr algn="ctr" indent="0" marL="0">
-              <a:buNone/>
-            </a:pPr>
-            <a:r>
-              <a:rPr lang="en-US" sz="1200" b="1" dirty="0">
-                <a:solidFill>
-                  <a:srgbClr val="FFFFFF"/>
-                </a:solidFill>
-                <a:latin typeface="Calibri" pitchFamily="34" charset="0"/>
-                <a:ea typeface="Calibri" pitchFamily="34" charset="-122"/>
-                <a:cs typeface="Calibri" pitchFamily="34" charset="-120"/>
-              </a:rPr>
-              <a:t>WORKFLOW</a:t>
-            </a:r>
-            <a:endParaRPr lang="en-US" sz="1200" dirty="0"/>
-          </a:p>
-        </p:txBody>
-      </p:sp>
-      <p:sp>
-        <p:nvSpPr>
-          <p:cNvPr id="4" name="Text 2"/>
-          <p:cNvSpPr/>
-          <p:nvPr/>
-        </p:nvSpPr>
-        <p:spPr>
-          <a:xfrm>
-            <a:off x="457200" y="658368"/>
-            <a:ext cx="9166225" cy="685800"/>
-          </a:xfrm>
-          <a:prstGeom prst="rect">
-            <a:avLst/>
-          </a:prstGeom>
-          <a:noFill/>
-          <a:ln/>
-        </p:spPr>
-        <p:txBody>
-          <a:bodyPr wrap="square" rtlCol="0" anchor="ctr"/>
-          <a:lstStyle/>
-          <a:p>
-            <a:pPr indent="0" marL="0">
-              <a:buNone/>
-            </a:pPr>
-            <a:r>
-              <a:rPr lang="en-US" sz="3000" b="1" dirty="0">
-                <a:solidFill>
-                  <a:srgbClr val="0C1B35"/>
-                </a:solidFill>
-                <a:latin typeface="Calibri" pitchFamily="34" charset="0"/>
-                <a:ea typeface="Calibri" pitchFamily="34" charset="-122"/>
-                <a:cs typeface="Calibri" pitchFamily="34" charset="-120"/>
-              </a:rPr>
-              <a:t>Spec-Driven Development vs. Vibe-Coding</a:t>
-            </a:r>
-            <a:endParaRPr lang="en-US" sz="3000" dirty="0"/>
-          </a:p>
-        </p:txBody>
-      </p:sp>
-      <p:sp>
-        <p:nvSpPr>
-          <p:cNvPr id="5" name="Shape 3"/>
-          <p:cNvSpPr/>
-          <p:nvPr/>
-        </p:nvSpPr>
-        <p:spPr>
-          <a:xfrm>
-            <a:off x="457200" y="1417320"/>
-            <a:ext cx="9166225" cy="27432"/>
-          </a:xfrm>
-          <a:prstGeom prst="rect">
-            <a:avLst/>
-          </a:prstGeom>
-          <a:solidFill>
-            <a:srgbClr val="1D6FBC"/>
-          </a:solidFill>
-          <a:ln w="12700">
-            <a:solidFill>
-              <a:srgbClr val="1D6FBC"/>
-            </a:solidFill>
-            <a:prstDash val="solid"/>
-          </a:ln>
-        </p:spPr>
-      </p:sp>
       <p:graphicFrame>
         <p:nvGraphicFramePr>
-          <p:cNvPr id="17" name="Table 0"/>
+          <p:cNvPr id="16" name="Table 0"/>
           <p:cNvGraphicFramePr>
             <a:graphicFrameLocks noGrp="1"/>
           </p:cNvGraphicFramePr>
@@ -6392,9 +6020,9 @@
 </p:sld>
 </file>
 
-<file path=ppt/slides/slide17.xml><?xml version="1.0" encoding="utf-8"?>
+<file path=ppt/slides/slide16.xml><?xml version="1.0" encoding="utf-8"?>
 <p:sld xmlns:a="http://schemas.openxmlformats.org/drawingml/2006/main" xmlns:r="http://schemas.openxmlformats.org/officeDocument/2006/relationships" xmlns:p="http://schemas.openxmlformats.org/presentationml/2006/main">
-  <p:cSld name="Slide 17">
+  <p:cSld name="Slide 16">
     <p:bg>
       <p:bgPr>
         <a:solidFill>
@@ -6546,7 +6174,7 @@
       </p:sp>
       <p:graphicFrame>
         <p:nvGraphicFramePr>
-          <p:cNvPr id="18" name="Table 0"/>
+          <p:cNvPr id="17" name="Table 0"/>
           <p:cNvGraphicFramePr>
             <a:graphicFrameLocks noGrp="1"/>
           </p:cNvGraphicFramePr>
@@ -7410,9 +7038,9 @@
 </p:sld>
 </file>
 
-<file path=ppt/slides/slide18.xml><?xml version="1.0" encoding="utf-8"?>
+<file path=ppt/slides/slide17.xml><?xml version="1.0" encoding="utf-8"?>
 <p:sld xmlns:a="http://schemas.openxmlformats.org/drawingml/2006/main" xmlns:r="http://schemas.openxmlformats.org/officeDocument/2006/relationships" xmlns:p="http://schemas.openxmlformats.org/presentationml/2006/main">
-  <p:cSld name="Slide 18">
+  <p:cSld name="Slide 17">
     <p:bg>
       <p:bgPr>
         <a:solidFill>

</xml_diff>

<commit_message>
Move opening-problem callback off the Traceability Spine slide face
The 4th bullet on slide 13 didn't fit the two-column layout and was
a different kind of statement (rhetorical callback) than the other
three (mechanism description), so it read as unrelated filler.
Restored the original mechanism-only bullet and moved the callback
into the speaker notes instead — still said out loud, just not
crammed onto the slide.

Co-Authored-By: Claude Sonnet 5 <noreply@anthropic.com>
</commit_message>
<xml_diff>
--- a/presentation/SpecDrivenDevelopment.pptx
+++ b/presentation/SpecDrivenDevelopment.pptx
@@ -958,7 +958,7 @@
           <a:p>
             <a:r>
               <a:rPr lang="en-US" dirty="0"/>
-              <a:t>This is the payoff concept — the thing that turns "we wrote some docs" into "we can prove the code matches the docs." Walk this as one concrete story, not four abstract bullets: FR-001 is real content from speckit-demo's actual generated Task List API, not a hypothetical. Land the last bullet as the callback to the opening problem from slide 2 — say the opening complaint out loud again before revealing this as its answer.</a:t>
+              <a:t>This is the payoff concept — the thing that turns "we wrote some docs" into "we can prove the code matches the docs." Walk this as one concrete story, not four abstract bullets: FR-001 is real content from speckit-demo's actual generated Task List API, not a hypothetical. This is also the direct answer to the opening problem from slide 2 — say that out loud before revealing this slide as its answer.</a:t>
             </a:r>
             <a:endParaRPr lang="en-US" dirty="0"/>
           </a:p>
@@ -4579,7 +4579,7 @@
                 <a:ea typeface="Calibri" pitchFamily="34" charset="-122"/>
                 <a:cs typeface="Calibri" pitchFamily="34" charset="-120"/>
               </a:rPr>
-              <a:t>This is the direct answer to the opening problem: nobody could check why the code was built this way before — now the link from decision to code is something you read, not something you take on faith</a:t>
+              <a:t>Follow the ID and you can point at the exact line of running code a one-sentence requirement became</a:t>
             </a:r>
             <a:endParaRPr lang="en-US" sz="1700" dirty="0"/>
           </a:p>

</xml_diff>